<commit_message>
docs: reframe slides 2-3 around user jobs and trust (product framing) + reproducible deck source
</commit_message>
<xml_diff>
--- a/docs/PartSelect-Chat-Agent-Deck.pptx
+++ b/docs/PartSelect-Chat-Agent-Deck.pptx
@@ -2588,17 +2588,17 @@
         </p:nvSpPr>
         <p:spPr>
           <a:xfrm>
-            <a:off x="4983480" y="2057400"/>
-            <a:ext cx="3429000" cy="2377440"/>
-          </a:xfrm>
-          <a:prstGeom prst="rect">
-            <a:avLst/>
-          </a:prstGeom>
-          <a:noFill/>
-          <a:ln/>
-        </p:spPr>
-        <p:txBody>
-          <a:bodyPr wrap="square" lIns="0" tIns="0" rIns="0" bIns="0" rtlCol="0" anchor="ctr"/>
+            <a:off x="4983480" y="2103120"/>
+            <a:ext cx="3429000" cy="2331720"/>
+          </a:xfrm>
+          <a:prstGeom prst="rect">
+            <a:avLst/>
+          </a:prstGeom>
+          <a:noFill/>
+          <a:ln/>
+        </p:spPr>
+        <p:txBody>
+          <a:bodyPr wrap="square" lIns="0" tIns="0" rIns="0" bIns="0" rtlCol="0" anchor="t"/>
           <a:lstStyle/>
           <a:p>
             <a:pPr marL="342900" indent="-342900">
@@ -3269,7 +3269,7 @@
                 <a:ea typeface="Calibri" pitchFamily="34" charset="-122"/>
                 <a:cs typeface="Calibri" pitchFamily="34" charset="-120"/>
               </a:rPr>
-              <a:t>   then ask it the three spec queries.</a:t>
+              <a:t>   then ask it the three user-job queries.</a:t>
             </a:r>
             <a:endParaRPr lang="en-US" sz="1400" dirty="0"/>
           </a:p>
@@ -3379,7 +3379,7 @@
                 <a:ea typeface="Trebuchet MS" pitchFamily="34" charset="-122"/>
                 <a:cs typeface="Trebuchet MS" pitchFamily="34" charset="-120"/>
               </a:rPr>
-              <a:t>Read the spec like an evaluator</a:t>
+              <a:t>Built around three user jobs</a:t>
             </a:r>
             <a:endParaRPr lang="en-US" sz="3000" dirty="0"/>
           </a:p>
@@ -3418,7 +3418,7 @@
                 <a:ea typeface="Calibri" pitchFamily="34" charset="-122"/>
                 <a:cs typeface="Calibri" pitchFamily="34" charset="-120"/>
               </a:rPr>
-              <a:t>Whoever grades this opens the app and types the three example queries first.</a:t>
+              <a:t>What does someone with a broken appliance actually want from a parts chat?</a:t>
             </a:r>
             <a:endParaRPr lang="en-US" sz="1350" dirty="0"/>
           </a:p>
@@ -3558,7 +3558,7 @@
                 <a:ea typeface="Calibri" pitchFamily="34" charset="-122"/>
                 <a:cs typeface="Calibri" pitchFamily="34" charset="-120"/>
               </a:rPr>
-              <a:t>exact part lookup + install help</a:t>
+              <a:t>→  I have the part — walk me through the install</a:t>
             </a:r>
             <a:endParaRPr lang="en-US" sz="1150" dirty="0"/>
           </a:p>
@@ -3698,7 +3698,7 @@
                 <a:ea typeface="Calibri" pitchFamily="34" charset="-122"/>
                 <a:cs typeface="Calibri" pitchFamily="34" charset="-120"/>
               </a:rPr>
-              <a:t>pronoun resolution + a compatibility claim</a:t>
+              <a:t>→  will this fit MY machine? (the money question)</a:t>
             </a:r>
             <a:endParaRPr lang="en-US" sz="1150" dirty="0"/>
           </a:p>
@@ -3838,7 +3838,7 @@
                 <a:ea typeface="Calibri" pitchFamily="34" charset="-122"/>
                 <a:cs typeface="Calibri" pitchFamily="34" charset="-120"/>
               </a:rPr>
-              <a:t>fuzzy symptom → diagnosis → part</a:t>
+              <a:t>→  something's broken — figure out what I need</a:t>
             </a:r>
             <a:endParaRPr lang="en-US" sz="1150" dirty="0"/>
           </a:p>
@@ -3904,7 +3904,7 @@
                 <a:ea typeface="Trebuchet MS" pitchFamily="34" charset="-122"/>
                 <a:cs typeface="Trebuchet MS" pitchFamily="34" charset="-120"/>
               </a:rPr>
-              <a:t>These aren't examples.</a:t>
+              <a:t>Jobs → flows → tests</a:t>
             </a:r>
             <a:endParaRPr lang="en-US" sz="1500" dirty="0"/>
           </a:p>
@@ -3943,7 +3943,7 @@
                 <a:ea typeface="Calibri" pitchFamily="34" charset="-122"/>
                 <a:cs typeface="Calibri" pitchFamily="34" charset="-120"/>
               </a:rPr>
-              <a:t>They're the acceptance tests — written before any code, automated in the eval harness, seeded as suggestion chips in the UI.</a:t>
+              <a:t>Each job became a product flow in the chat — install help, fit checks, diagnosis — and an automated test that gates every change.</a:t>
             </a:r>
             <a:endParaRPr lang="en-US" sz="1150" dirty="0"/>
           </a:p>
@@ -4007,7 +4007,7 @@
                 <a:ea typeface="Calibri" pitchFamily="34" charset="-122"/>
                 <a:cs typeface="Calibri" pitchFamily="34" charset="-120"/>
               </a:rPr>
-              <a:t>Strategy:  </a:t>
+              <a:t>Product principle:  </a:t>
             </a:r>
             <a:pPr indent="0" marL="0">
               <a:buNone/>
@@ -4021,7 +4021,7 @@
                 <a:ea typeface="Calibri" pitchFamily="34" charset="-122"/>
                 <a:cs typeface="Calibri" pitchFamily="34" charset="-120"/>
               </a:rPr>
-              <a:t>every candidate ships a branded chat + an LLM + a few tools. The differentiator is </a:t>
+              <a:t>a parts assistant is only useful if every answer can be trusted — wrong part numbers mean wrong orders and returns. So </a:t>
             </a:r>
             <a:pPr indent="0" marL="0">
               <a:buNone/>
@@ -4035,7 +4035,7 @@
                 <a:ea typeface="Calibri" pitchFamily="34" charset="-122"/>
                 <a:cs typeface="Calibri" pitchFamily="34" charset="-120"/>
               </a:rPr>
-              <a:t>proof</a:t>
+              <a:t>accuracy is a feature</a:t>
             </a:r>
             <a:pPr indent="0" marL="0">
               <a:buNone/>
@@ -4049,7 +4049,7 @@
                 <a:ea typeface="Calibri" pitchFamily="34" charset="-122"/>
                 <a:cs typeface="Calibri" pitchFamily="34" charset="-120"/>
               </a:rPr>
-              <a:t> — a measured agent, honest about its data, that a grader can verify in five minutes.</a:t>
+              <a:t>, and it's measured like one.</a:t>
             </a:r>
             <a:endParaRPr lang="en-US" sz="1250" dirty="0"/>
           </a:p>
@@ -4120,7 +4120,7 @@
                 <a:ea typeface="Trebuchet MS" pitchFamily="34" charset="-122"/>
                 <a:cs typeface="Trebuchet MS" pitchFamily="34" charset="-120"/>
               </a:rPr>
-              <a:t>Recon found a trap in the spec itself</a:t>
+              <a:t>Why trust is the hard part</a:t>
             </a:r>
             <a:endParaRPr lang="en-US" sz="3000" dirty="0"/>
           </a:p>
@@ -4159,7 +4159,7 @@
                 <a:ea typeface="Calibri" pitchFamily="34" charset="-122"/>
                 <a:cs typeface="Calibri" pitchFamily="34" charset="-120"/>
               </a:rPr>
-              <a:t>Before designing anything, I pulled the real pages for the example queries.</a:t>
+              <a:t>I pulled the real PartSelect pages for those queries before designing anything. Look closely:</a:t>
             </a:r>
             <a:endParaRPr lang="en-US" sz="1350" dirty="0"/>
           </a:p>
@@ -4618,7 +4618,7 @@
               <a:buNone/>
             </a:pPr>
             <a:r>
-              <a:rPr lang="en-US" sz="1400" b="1" dirty="0">
+              <a:rPr lang="en-US" sz="1350" b="1" dirty="0">
                 <a:solidFill>
                   <a:srgbClr val="F3C04C"/>
                 </a:solidFill>
@@ -4626,9 +4626,9 @@
                 <a:ea typeface="Calibri" pitchFamily="34" charset="-122"/>
                 <a:cs typeface="Calibri" pitchFamily="34" charset="-120"/>
               </a:rPr>
-              <a:t>Spec query 2 is a hallucination trap:</a:t>
-            </a:r>
-            <a:endParaRPr lang="en-US" sz="1400" dirty="0"/>
+              <a:t>Real customers mix up parts and models constantly — example query 2 does it too.</a:t>
+            </a:r>
+            <a:endParaRPr lang="en-US" sz="1350" dirty="0"/>
           </a:p>
           <a:p>
             <a:pPr indent="0" marL="0">
@@ -4643,9 +4643,9 @@
                 <a:ea typeface="Calibri" pitchFamily="34" charset="-122"/>
                 <a:cs typeface="Calibri" pitchFamily="34" charset="-120"/>
               </a:rPr>
-              <a:t>a fridge bin can't fit a dishwasher — any agent that says “yes, compatible!” is making it up. This one fact dictated the architecture: compatibility is a database JOIN, never an LLM guess.</a:t>
-            </a:r>
-            <a:endParaRPr lang="en-US" sz="1400" dirty="0"/>
+              <a:t>A chatbot that confidently says “yes, it fits!” here causes a wrong order, a return, and lost trust. So in this product, compatibility comes from a database JOIN over scraped fitment data — the LLM never gets to guess.</a:t>
+            </a:r>
+            <a:endParaRPr lang="en-US" sz="1350" dirty="0"/>
           </a:p>
         </p:txBody>
       </p:sp>
@@ -7256,7 +7256,7 @@
               <a:buNone/>
             </a:pPr>
             <a:r>
-              <a:rPr lang="en-US" sz="3000" b="1" dirty="0">
+              <a:rPr lang="en-US" sz="2900" b="1" dirty="0">
                 <a:solidFill>
                   <a:srgbClr val="FFFFFF"/>
                 </a:solidFill>
@@ -7264,9 +7264,9 @@
                 <a:ea typeface="Trebuchet MS" pitchFamily="34" charset="-122"/>
                 <a:cs typeface="Trebuchet MS" pitchFamily="34" charset="-120"/>
               </a:rPr>
-              <a:t>The differentiator: a measured agent</a:t>
-            </a:r>
-            <a:endParaRPr lang="en-US" sz="3000" dirty="0"/>
+              <a:t>Accuracy is a feature — so it's measured</a:t>
+            </a:r>
+            <a:endParaRPr lang="en-US" sz="2900" dirty="0"/>
           </a:p>
         </p:txBody>
       </p:sp>
@@ -7737,7 +7737,7 @@
                 <a:ea typeface="Calibri" pitchFamily="34" charset="-122"/>
                 <a:cs typeface="Calibri" pitchFamily="34" charset="-120"/>
               </a:rPr>
-              <a:t>Suites: spec-canonical 3/3 · compatibility 8/8 · fuzzy search 6/6 · diagnosis 6/6 · scope 8/8 · injection 4/4 · grounding 5/5</a:t>
+              <a:t>Suites: user-job canonical 3/3 · compatibility 8/8 · fuzzy search 6/6 · diagnosis 6/6 · scope 8/8 · injection 4/4 · grounding 5/5</a:t>
             </a:r>
             <a:endParaRPr lang="en-US" sz="1200" dirty="0"/>
           </a:p>

</xml_diff>